<commit_message>
Add parallel plugin + engine integration
</commit_message>
<xml_diff>
--- a/demo/hcompress-demo.pptx
+++ b/demo/hcompress-demo.pptx
@@ -15,6 +15,7 @@
     <p:sldId id="263" r:id="rId14"/>
     <p:sldId id="264" r:id="rId15"/>
     <p:sldId id="265" r:id="rId16"/>
+    <p:sldId id="266" r:id="rId17"/>
   </p:sldIdLst>
   <p:sldSz cx="12191695" cy="6858000" type="screen4x3"/>
   <p:notesSz cx="6858000" cy="9144000"/>
@@ -3320,6 +3321,422 @@
       <p:grpSpPr/>
       <p:sp>
         <p:nvSpPr>
+          <p:cNvPr id="2" name="TextBox 1"/>
+          <p:cNvSpPr txBox="1"/>
+          <p:nvPr/>
+        </p:nvSpPr>
+        <p:spPr>
+          <a:xfrm>
+            <a:off x="731520" y="457200"/>
+            <a:ext cx="9144000" cy="548640"/>
+          </a:xfrm>
+          <a:prstGeom prst="rect">
+            <a:avLst/>
+          </a:prstGeom>
+          <a:noFill/>
+        </p:spPr>
+        <p:txBody>
+          <a:bodyPr wrap="square">
+            <a:spAutoFit/>
+          </a:bodyPr>
+          <a:lstStyle/>
+          <a:p>
+            <a:pPr algn="l">
+              <a:defRPr sz="3200" b="1">
+                <a:solidFill>
+                  <a:srgbClr val="1A1A1A"/>
+                </a:solidFill>
+                <a:latin typeface="Segoe UI"/>
+              </a:defRPr>
+            </a:pPr>
+            <a:r>
+              <a:t>v2 桌面端 — Electron + React</a:t>
+            </a:r>
+          </a:p>
+        </p:txBody>
+      </p:sp>
+      <p:sp>
+        <p:nvSpPr>
+          <p:cNvPr id="3" name="Rectangle 2"/>
+          <p:cNvSpPr/>
+          <p:nvPr/>
+        </p:nvSpPr>
+        <p:spPr>
+          <a:xfrm>
+            <a:off x="731520" y="1097280"/>
+            <a:ext cx="10698480" cy="19050"/>
+          </a:xfrm>
+          <a:prstGeom prst="rect">
+            <a:avLst/>
+          </a:prstGeom>
+          <a:solidFill>
+            <a:srgbClr val="E0E0E0"/>
+          </a:solidFill>
+          <a:ln>
+            <a:noFill/>
+          </a:ln>
+        </p:spPr>
+        <p:style>
+          <a:lnRef idx="1">
+            <a:schemeClr val="accent1"/>
+          </a:lnRef>
+          <a:fillRef idx="3">
+            <a:schemeClr val="accent1"/>
+          </a:fillRef>
+          <a:effectRef idx="2">
+            <a:schemeClr val="accent1"/>
+          </a:effectRef>
+          <a:fontRef idx="minor">
+            <a:schemeClr val="lt1"/>
+          </a:fontRef>
+        </p:style>
+        <p:txBody>
+          <a:bodyPr rtlCol="0" anchor="ctr"/>
+          <a:lstStyle/>
+          <a:p>
+            <a:pPr algn="ctr"/>
+          </a:p>
+        </p:txBody>
+      </p:sp>
+      <p:sp>
+        <p:nvSpPr>
+          <p:cNvPr id="4" name="Rectangle 3"/>
+          <p:cNvSpPr/>
+          <p:nvPr/>
+        </p:nvSpPr>
+        <p:spPr>
+          <a:xfrm>
+            <a:off x="731520" y="1463040"/>
+            <a:ext cx="7132320" cy="4937760"/>
+          </a:xfrm>
+          <a:prstGeom prst="rect">
+            <a:avLst/>
+          </a:prstGeom>
+          <a:solidFill>
+            <a:srgbClr val="F5F5F5"/>
+          </a:solidFill>
+          <a:ln w="12700">
+            <a:solidFill>
+              <a:srgbClr val="999999"/>
+            </a:solidFill>
+            <a:prstDash val="sysDash"/>
+          </a:ln>
+        </p:spPr>
+        <p:style>
+          <a:lnRef idx="1">
+            <a:schemeClr val="accent1"/>
+          </a:lnRef>
+          <a:fillRef idx="3">
+            <a:schemeClr val="accent1"/>
+          </a:fillRef>
+          <a:effectRef idx="2">
+            <a:schemeClr val="accent1"/>
+          </a:effectRef>
+          <a:fontRef idx="minor">
+            <a:schemeClr val="lt1"/>
+          </a:fontRef>
+        </p:style>
+        <p:txBody>
+          <a:bodyPr rtlCol="0" anchor="ctr" wrap="square"/>
+          <a:lstStyle/>
+          <a:p>
+            <a:pPr algn="ctr">
+              <a:spcBef>
+                <a:spcPts val="600"/>
+              </a:spcBef>
+              <a:defRPr sz="1300">
+                <a:solidFill>
+                  <a:srgbClr val="999999"/>
+                </a:solidFill>
+                <a:latin typeface="Segoe UI"/>
+              </a:defRPr>
+            </a:pPr>
+            <a:r>
+              <a:t>📷 v2 GUI 完整截图（含三主题对比）</a:t>
+            </a:r>
+          </a:p>
+        </p:txBody>
+      </p:sp>
+      <p:sp>
+        <p:nvSpPr>
+          <p:cNvPr id="5" name="TextBox 4"/>
+          <p:cNvSpPr txBox="1"/>
+          <p:nvPr/>
+        </p:nvSpPr>
+        <p:spPr>
+          <a:xfrm>
+            <a:off x="8229600" y="1645920"/>
+            <a:ext cx="3474720" cy="365760"/>
+          </a:xfrm>
+          <a:prstGeom prst="rect">
+            <a:avLst/>
+          </a:prstGeom>
+          <a:noFill/>
+        </p:spPr>
+        <p:txBody>
+          <a:bodyPr wrap="square">
+            <a:spAutoFit/>
+          </a:bodyPr>
+          <a:lstStyle/>
+          <a:p>
+            <a:pPr algn="l">
+              <a:defRPr sz="1400" b="0">
+                <a:solidFill>
+                  <a:srgbClr val="333333"/>
+                </a:solidFill>
+                <a:latin typeface="Segoe UI"/>
+              </a:defRPr>
+            </a:pPr>
+            <a:r>
+              <a:t>☀️/💻/🌙 三主题切换</a:t>
+            </a:r>
+          </a:p>
+        </p:txBody>
+      </p:sp>
+      <p:sp>
+        <p:nvSpPr>
+          <p:cNvPr id="6" name="TextBox 5"/>
+          <p:cNvSpPr txBox="1"/>
+          <p:nvPr/>
+        </p:nvSpPr>
+        <p:spPr>
+          <a:xfrm>
+            <a:off x="8229600" y="2148840"/>
+            <a:ext cx="3474720" cy="365760"/>
+          </a:xfrm>
+          <a:prstGeom prst="rect">
+            <a:avLst/>
+          </a:prstGeom>
+          <a:noFill/>
+        </p:spPr>
+        <p:txBody>
+          <a:bodyPr wrap="square">
+            <a:spAutoFit/>
+          </a:bodyPr>
+          <a:lstStyle/>
+          <a:p>
+            <a:pPr algn="l">
+              <a:defRPr sz="1400" b="0">
+                <a:solidFill>
+                  <a:srgbClr val="333333"/>
+                </a:solidFill>
+                <a:latin typeface="Segoe UI"/>
+              </a:defRPr>
+            </a:pPr>
+            <a:r>
+              <a:t>拖拽上传 + 文件列表</a:t>
+            </a:r>
+          </a:p>
+        </p:txBody>
+      </p:sp>
+      <p:sp>
+        <p:nvSpPr>
+          <p:cNvPr id="7" name="TextBox 6"/>
+          <p:cNvSpPr txBox="1"/>
+          <p:nvPr/>
+        </p:nvSpPr>
+        <p:spPr>
+          <a:xfrm>
+            <a:off x="8229600" y="2651760"/>
+            <a:ext cx="3474720" cy="365760"/>
+          </a:xfrm>
+          <a:prstGeom prst="rect">
+            <a:avLst/>
+          </a:prstGeom>
+          <a:noFill/>
+        </p:spPr>
+        <p:txBody>
+          <a:bodyPr wrap="square">
+            <a:spAutoFit/>
+          </a:bodyPr>
+          <a:lstStyle/>
+          <a:p>
+            <a:pPr algn="l">
+              <a:defRPr sz="1400" b="0">
+                <a:solidFill>
+                  <a:srgbClr val="333333"/>
+                </a:solidFill>
+                <a:latin typeface="Segoe UI"/>
+              </a:defRPr>
+            </a:pPr>
+            <a:r>
+              <a:t>压缩率实时估算</a:t>
+            </a:r>
+          </a:p>
+        </p:txBody>
+      </p:sp>
+      <p:sp>
+        <p:nvSpPr>
+          <p:cNvPr id="8" name="TextBox 7"/>
+          <p:cNvSpPr txBox="1"/>
+          <p:nvPr/>
+        </p:nvSpPr>
+        <p:spPr>
+          <a:xfrm>
+            <a:off x="8229600" y="3154680"/>
+            <a:ext cx="3474720" cy="365760"/>
+          </a:xfrm>
+          <a:prstGeom prst="rect">
+            <a:avLst/>
+          </a:prstGeom>
+          <a:noFill/>
+        </p:spPr>
+        <p:txBody>
+          <a:bodyPr wrap="square">
+            <a:spAutoFit/>
+          </a:bodyPr>
+          <a:lstStyle/>
+          <a:p>
+            <a:pPr algn="l">
+              <a:defRPr sz="1400" b="0">
+                <a:solidFill>
+                  <a:srgbClr val="333333"/>
+                </a:solidFill>
+                <a:latin typeface="Segoe UI"/>
+              </a:defRPr>
+            </a:pPr>
+            <a:r>
+              <a:t>插件管理面板（开关 + 状态）</a:t>
+            </a:r>
+          </a:p>
+        </p:txBody>
+      </p:sp>
+      <p:sp>
+        <p:nvSpPr>
+          <p:cNvPr id="9" name="TextBox 8"/>
+          <p:cNvSpPr txBox="1"/>
+          <p:nvPr/>
+        </p:nvSpPr>
+        <p:spPr>
+          <a:xfrm>
+            <a:off x="8229600" y="3657600"/>
+            <a:ext cx="3474720" cy="365760"/>
+          </a:xfrm>
+          <a:prstGeom prst="rect">
+            <a:avLst/>
+          </a:prstGeom>
+          <a:noFill/>
+        </p:spPr>
+        <p:txBody>
+          <a:bodyPr wrap="square">
+            <a:spAutoFit/>
+          </a:bodyPr>
+          <a:lstStyle/>
+          <a:p>
+            <a:pPr algn="l">
+              <a:defRPr sz="1400" b="0">
+                <a:solidFill>
+                  <a:srgbClr val="333333"/>
+                </a:solidFill>
+                <a:latin typeface="Segoe UI"/>
+              </a:defRPr>
+            </a:pPr>
+            <a:r>
+              <a:t>BombGuard 可视化拦截弹窗</a:t>
+            </a:r>
+          </a:p>
+        </p:txBody>
+      </p:sp>
+      <p:sp>
+        <p:nvSpPr>
+          <p:cNvPr id="10" name="TextBox 9"/>
+          <p:cNvSpPr txBox="1"/>
+          <p:nvPr/>
+        </p:nvSpPr>
+        <p:spPr>
+          <a:xfrm>
+            <a:off x="8229600" y="4160520"/>
+            <a:ext cx="3474720" cy="365760"/>
+          </a:xfrm>
+          <a:prstGeom prst="rect">
+            <a:avLst/>
+          </a:prstGeom>
+          <a:noFill/>
+        </p:spPr>
+        <p:txBody>
+          <a:bodyPr wrap="square">
+            <a:spAutoFit/>
+          </a:bodyPr>
+          <a:lstStyle/>
+          <a:p>
+            <a:pPr algn="l">
+              <a:defRPr sz="1400" b="0">
+                <a:solidFill>
+                  <a:srgbClr val="333333"/>
+                </a:solidFill>
+                <a:latin typeface="Segoe UI"/>
+              </a:defRPr>
+            </a:pPr>
+            <a:r>
+              <a:t>归档浏览器</a:t>
+            </a:r>
+          </a:p>
+        </p:txBody>
+      </p:sp>
+      <p:sp>
+        <p:nvSpPr>
+          <p:cNvPr id="11" name="TextBox 10"/>
+          <p:cNvSpPr txBox="1"/>
+          <p:nvPr/>
+        </p:nvSpPr>
+        <p:spPr>
+          <a:xfrm>
+            <a:off x="8229600" y="4663440"/>
+            <a:ext cx="3474720" cy="365760"/>
+          </a:xfrm>
+          <a:prstGeom prst="rect">
+            <a:avLst/>
+          </a:prstGeom>
+          <a:noFill/>
+        </p:spPr>
+        <p:txBody>
+          <a:bodyPr wrap="square">
+            <a:spAutoFit/>
+          </a:bodyPr>
+          <a:lstStyle/>
+          <a:p>
+            <a:pPr algn="l">
+              <a:defRPr sz="1400" b="0">
+                <a:solidFill>
+                  <a:srgbClr val="333333"/>
+                </a:solidFill>
+                <a:latin typeface="Segoe UI"/>
+              </a:defRPr>
+            </a:pPr>
+            <a:r>
+              <a:t>F11 全屏模式</a:t>
+            </a:r>
+          </a:p>
+        </p:txBody>
+      </p:sp>
+    </p:spTree>
+  </p:cSld>
+  <p:clrMapOvr>
+    <a:masterClrMapping/>
+  </p:clrMapOvr>
+</p:sld>
+</file>
+
+<file path=ppt/slides/slide11.xml><?xml version="1.0" encoding="utf-8"?>
+<p:sld xmlns:a="http://schemas.openxmlformats.org/drawingml/2006/main" xmlns:p="http://schemas.openxmlformats.org/presentationml/2006/main" xmlns:r="http://schemas.openxmlformats.org/officeDocument/2006/relationships">
+  <p:cSld>
+    <p:bg>
+      <p:bgPr>
+        <a:solidFill>
+          <a:srgbClr val="FFFFFF"/>
+        </a:solidFill>
+        <a:effectLst/>
+      </p:bgPr>
+    </p:bg>
+    <p:spTree>
+      <p:nvGrpSpPr>
+        <p:cNvPr id="1" name=""/>
+        <p:cNvGrpSpPr/>
+        <p:nvPr/>
+      </p:nvGrpSpPr>
+      <p:grpSpPr/>
+      <p:sp>
+        <p:nvSpPr>
           <p:cNvPr id="2" name="Rectangle 1"/>
           <p:cNvSpPr/>
           <p:nvPr/>
@@ -6495,7 +6912,7 @@
               </a:defRPr>
             </a:pPr>
             <a:r>
-              <a:t>• 编码加速 4.4×（385ms → 88ms）</a:t>
+              <a:t>• C 扩展编码加速 4.4×（385ms → 88ms）</a:t>
             </a:r>
           </a:p>
         </p:txBody>
@@ -6531,7 +6948,7 @@
               </a:defRPr>
             </a:pPr>
             <a:r>
-              <a:t>• 解码加速 29.5×（809ms → 28ms）</a:t>
+              <a:t>• C 扩展解码加速 29.5×（809ms → 28ms）</a:t>
             </a:r>
           </a:p>
         </p:txBody>
@@ -6567,7 +6984,7 @@
               </a:defRPr>
             </a:pPr>
             <a:r>
-              <a:t>• 文本压缩率稳定 50% 左右</a:t>
+              <a:t>• 多进程压缩加速 3.1×（4 workers: 900ms → 291ms）</a:t>
             </a:r>
           </a:p>
         </p:txBody>
@@ -6603,7 +7020,7 @@
               </a:defRPr>
             </a:pPr>
             <a:r>
-              <a:t>• 速度约 5-6 MB/s（当前 Python 瓶颈在 I/O）</a:t>
+              <a:t>• 文本压缩率稳定 50% 左右</a:t>
             </a:r>
           </a:p>
         </p:txBody>
@@ -6640,6 +7057,42 @@
             </a:pPr>
             <a:r>
               <a:t>• 二进制/已压缩文件 — 几乎无效果（正常现象）</a:t>
+            </a:r>
+          </a:p>
+        </p:txBody>
+      </p:sp>
+      <p:sp>
+        <p:nvSpPr>
+          <p:cNvPr id="12" name="TextBox 11"/>
+          <p:cNvSpPr txBox="1"/>
+          <p:nvPr/>
+        </p:nvSpPr>
+        <p:spPr>
+          <a:xfrm>
+            <a:off x="731520" y="6675120"/>
+            <a:ext cx="10058400" cy="320040"/>
+          </a:xfrm>
+          <a:prstGeom prst="rect">
+            <a:avLst/>
+          </a:prstGeom>
+          <a:noFill/>
+        </p:spPr>
+        <p:txBody>
+          <a:bodyPr wrap="square">
+            <a:spAutoFit/>
+          </a:bodyPr>
+          <a:lstStyle/>
+          <a:p>
+            <a:pPr algn="l">
+              <a:defRPr sz="1300" b="0">
+                <a:solidFill>
+                  <a:srgbClr val="666666"/>
+                </a:solidFill>
+                <a:latin typeface="Segoe UI"/>
+              </a:defRPr>
+            </a:pPr>
+            <a:r>
+              <a:t>• Python GIL 绕过：ProcessPoolExecutor + C 扩展</a:t>
             </a:r>
           </a:p>
         </p:txBody>
@@ -6701,7 +7154,7 @@
               </a:defRPr>
             </a:pPr>
             <a:r>
-              <a:t>插件架构</a:t>
+              <a:t>多进程并行压缩</a:t>
             </a:r>
           </a:p>
         </p:txBody>
@@ -6758,7 +7211,7 @@
         <p:spPr>
           <a:xfrm>
             <a:off x="731520" y="1463040"/>
-            <a:ext cx="5943600" cy="4937760"/>
+            <a:ext cx="5486400" cy="4937760"/>
           </a:xfrm>
           <a:prstGeom prst="rect">
             <a:avLst/>
@@ -6803,7 +7256,7 @@
               </a:defRPr>
             </a:pPr>
             <a:r>
-              <a:t>📷 接口关系图 — 建议用 demo/index.html 的接口力导向图</a:t>
+              <a:t>📷 多线程架构图 / 性能对比图</a:t>
             </a:r>
           </a:p>
         </p:txBody>
@@ -6816,7 +7269,7 @@
         </p:nvSpPr>
         <p:spPr>
           <a:xfrm>
-            <a:off x="7132320" y="1463040"/>
+            <a:off x="6858000" y="1463040"/>
             <a:ext cx="4572000" cy="365760"/>
           </a:xfrm>
           <a:prstGeom prst="rect">
@@ -6831,7 +7284,7 @@
           <a:lstStyle/>
           <a:p>
             <a:pPr algn="l">
-              <a:defRPr sz="1800" b="1">
+              <a:defRPr sz="2000" b="1">
                 <a:solidFill>
                   <a:srgbClr val="1A1A1A"/>
                 </a:solidFill>
@@ -6839,7 +7292,7 @@
               </a:defRPr>
             </a:pPr>
             <a:r>
-              <a:t>10 个可扩展接口</a:t>
+              <a:t>ProcessPoolExecutor</a:t>
             </a:r>
           </a:p>
         </p:txBody>
@@ -6852,7 +7305,7 @@
         </p:nvSpPr>
         <p:spPr>
           <a:xfrm>
-            <a:off x="7132320" y="2011680"/>
+            <a:off x="6858000" y="2011680"/>
             <a:ext cx="4572000" cy="320040"/>
           </a:xfrm>
           <a:prstGeom prst="rect">
@@ -6867,15 +7320,15 @@
           <a:lstStyle/>
           <a:p>
             <a:pPr algn="l">
-              <a:defRPr sz="1200" b="0">
+              <a:defRPr sz="1300" b="0">
                 <a:solidFill>
                   <a:srgbClr val="333333"/>
                 </a:solidFill>
-                <a:latin typeface="Cascadia Code"/>
-              </a:defRPr>
-            </a:pPr>
-            <a:r>
-              <a:t>IEntropyCodec — 熵编码算法</a:t>
+                <a:latin typeface="Segoe UI"/>
+              </a:defRPr>
+            </a:pPr>
+            <a:r>
+              <a:t>• Python GIL 绕过：多进程替代多线程</a:t>
             </a:r>
           </a:p>
         </p:txBody>
@@ -6888,7 +7341,7 @@
         </p:nvSpPr>
         <p:spPr>
           <a:xfrm>
-            <a:off x="7132320" y="2395728"/>
+            <a:off x="6858000" y="2359152"/>
             <a:ext cx="4572000" cy="320040"/>
           </a:xfrm>
           <a:prstGeom prst="rect">
@@ -6903,15 +7356,15 @@
           <a:lstStyle/>
           <a:p>
             <a:pPr algn="l">
-              <a:defRPr sz="1200" b="0">
+              <a:defRPr sz="1300" b="0">
                 <a:solidFill>
                   <a:srgbClr val="333333"/>
                 </a:solidFill>
-                <a:latin typeface="Cascadia Code"/>
-              </a:defRPr>
-            </a:pPr>
-            <a:r>
-              <a:t>ITransform — 数据变换 (BWT/MTF/RLE)</a:t>
+                <a:latin typeface="Segoe UI"/>
+              </a:defRPr>
+            </a:pPr>
+            <a:r>
+              <a:t>• 大文件自动分块，每块独立压缩</a:t>
             </a:r>
           </a:p>
         </p:txBody>
@@ -6924,7 +7377,7 @@
         </p:nvSpPr>
         <p:spPr>
           <a:xfrm>
-            <a:off x="7132320" y="2779776"/>
+            <a:off x="6858000" y="2706624"/>
             <a:ext cx="4572000" cy="320040"/>
           </a:xfrm>
           <a:prstGeom prst="rect">
@@ -6939,15 +7392,15 @@
           <a:lstStyle/>
           <a:p>
             <a:pPr algn="l">
-              <a:defRPr sz="1200" b="0">
+              <a:defRPr sz="1300" b="0">
                 <a:solidFill>
                   <a:srgbClr val="333333"/>
                 </a:solidFill>
-                <a:latin typeface="Cascadia Code"/>
-              </a:defRPr>
-            </a:pPr>
-            <a:r>
-              <a:t>IFilter — 预处理过滤器</a:t>
+                <a:latin typeface="Segoe UI"/>
+              </a:defRPr>
+            </a:pPr>
+            <a:r>
+              <a:t>• C 扩展 + 多进程 = 最大性能</a:t>
             </a:r>
           </a:p>
         </p:txBody>
@@ -6960,7 +7413,7 @@
         </p:nvSpPr>
         <p:spPr>
           <a:xfrm>
-            <a:off x="7132320" y="3163824"/>
+            <a:off x="6858000" y="3054096"/>
             <a:ext cx="4572000" cy="320040"/>
           </a:xfrm>
           <a:prstGeom prst="rect">
@@ -6975,16 +7428,13 @@
           <a:lstStyle/>
           <a:p>
             <a:pPr algn="l">
-              <a:defRPr sz="1200" b="0">
+              <a:defRPr sz="1300" b="0">
                 <a:solidFill>
                   <a:srgbClr val="333333"/>
                 </a:solidFill>
-                <a:latin typeface="Cascadia Code"/>
-              </a:defRPr>
-            </a:pPr>
-            <a:r>
-              <a:t>IMatchFinder — LZ77 字典匹配</a:t>
-            </a:r>
+                <a:latin typeface="Segoe UI"/>
+              </a:defRPr>
+            </a:pPr>
           </a:p>
         </p:txBody>
       </p:sp>
@@ -6996,7 +7446,7 @@
         </p:nvSpPr>
         <p:spPr>
           <a:xfrm>
-            <a:off x="7132320" y="3547872"/>
+            <a:off x="6858000" y="3401568"/>
             <a:ext cx="4572000" cy="320040"/>
           </a:xfrm>
           <a:prstGeom prst="rect">
@@ -7011,15 +7461,15 @@
           <a:lstStyle/>
           <a:p>
             <a:pPr algn="l">
-              <a:defRPr sz="1200" b="0">
+              <a:defRPr sz="1300" b="0">
                 <a:solidFill>
                   <a:srgbClr val="333333"/>
                 </a:solidFill>
-                <a:latin typeface="Cascadia Code"/>
-              </a:defRPr>
-            </a:pPr>
-            <a:r>
-              <a:t>IChecksum — 完整性校验</a:t>
+                <a:latin typeface="Segoe UI"/>
+              </a:defRPr>
+            </a:pPr>
+            <a:r>
+              <a:t>实测数据（5.2 MB 文本）：</a:t>
             </a:r>
           </a:p>
         </p:txBody>
@@ -7032,7 +7482,7 @@
         </p:nvSpPr>
         <p:spPr>
           <a:xfrm>
-            <a:off x="7132320" y="3931920"/>
+            <a:off x="6858000" y="3749039"/>
             <a:ext cx="4572000" cy="320040"/>
           </a:xfrm>
           <a:prstGeom prst="rect">
@@ -7047,15 +7497,15 @@
           <a:lstStyle/>
           <a:p>
             <a:pPr algn="l">
-              <a:defRPr sz="1200" b="0">
+              <a:defRPr sz="1300" b="0">
                 <a:solidFill>
                   <a:srgbClr val="333333"/>
                 </a:solidFill>
-                <a:latin typeface="Cascadia Code"/>
-              </a:defRPr>
-            </a:pPr>
-            <a:r>
-              <a:t>IIOBackend — IO 后端</a:t>
+                <a:latin typeface="Segoe UI"/>
+              </a:defRPr>
+            </a:pPr>
+            <a:r>
+              <a:t>  单线程:  900 ms</a:t>
             </a:r>
           </a:p>
         </p:txBody>
@@ -7068,7 +7518,7 @@
         </p:nvSpPr>
         <p:spPr>
           <a:xfrm>
-            <a:off x="7132320" y="4315968"/>
+            <a:off x="6858000" y="4096512"/>
             <a:ext cx="4572000" cy="320040"/>
           </a:xfrm>
           <a:prstGeom prst="rect">
@@ -7083,15 +7533,15 @@
           <a:lstStyle/>
           <a:p>
             <a:pPr algn="l">
-              <a:defRPr sz="1200" b="0">
+              <a:defRPr sz="1300" b="0">
                 <a:solidFill>
                   <a:srgbClr val="333333"/>
                 </a:solidFill>
-                <a:latin typeface="Cascadia Code"/>
-              </a:defRPr>
-            </a:pPr>
-            <a:r>
-              <a:t>IBlockSplitter — 分块策略</a:t>
+                <a:latin typeface="Segoe UI"/>
+              </a:defRPr>
+            </a:pPr>
+            <a:r>
+              <a:t>  2 进程:  377 ms (2.4×)</a:t>
             </a:r>
           </a:p>
         </p:txBody>
@@ -7104,7 +7554,7 @@
         </p:nvSpPr>
         <p:spPr>
           <a:xfrm>
-            <a:off x="7132320" y="4700016"/>
+            <a:off x="6858000" y="4443984"/>
             <a:ext cx="4572000" cy="320040"/>
           </a:xfrm>
           <a:prstGeom prst="rect">
@@ -7119,15 +7569,15 @@
           <a:lstStyle/>
           <a:p>
             <a:pPr algn="l">
-              <a:defRPr sz="1200" b="0">
+              <a:defRPr sz="1300" b="0">
                 <a:solidFill>
                   <a:srgbClr val="333333"/>
                 </a:solidFill>
-                <a:latin typeface="Cascadia Code"/>
-              </a:defRPr>
-            </a:pPr>
-            <a:r>
-              <a:t>ICompressHook / IDecompressHook</a:t>
+                <a:latin typeface="Segoe UI"/>
+              </a:defRPr>
+            </a:pPr>
+            <a:r>
+              <a:t>  4 进程:  291 ms (3.1×)</a:t>
             </a:r>
           </a:p>
         </p:txBody>
@@ -7140,7 +7590,7 @@
         </p:nvSpPr>
         <p:spPr>
           <a:xfrm>
-            <a:off x="7132320" y="5084064"/>
+            <a:off x="6858000" y="4791456"/>
             <a:ext cx="4572000" cy="320040"/>
           </a:xfrm>
           <a:prstGeom prst="rect">
@@ -7155,16 +7605,13 @@
           <a:lstStyle/>
           <a:p>
             <a:pPr algn="l">
-              <a:defRPr sz="1200" b="0">
+              <a:defRPr sz="1300" b="0">
                 <a:solidFill>
                   <a:srgbClr val="333333"/>
                 </a:solidFill>
-                <a:latin typeface="Cascadia Code"/>
-              </a:defRPr>
-            </a:pPr>
-            <a:r>
-              <a:t>IObserver — 进度/日志</a:t>
-            </a:r>
+                <a:latin typeface="Segoe UI"/>
+              </a:defRPr>
+            </a:pPr>
           </a:p>
         </p:txBody>
       </p:sp>
@@ -7176,7 +7623,7 @@
         </p:nvSpPr>
         <p:spPr>
           <a:xfrm>
-            <a:off x="7132320" y="5468112"/>
+            <a:off x="6858000" y="5138928"/>
             <a:ext cx="4572000" cy="320040"/>
           </a:xfrm>
           <a:prstGeom prst="rect">
@@ -7191,15 +7638,15 @@
           <a:lstStyle/>
           <a:p>
             <a:pPr algn="l">
-              <a:defRPr sz="1200" b="0">
+              <a:defRPr sz="1300" b="0">
                 <a:solidFill>
                   <a:srgbClr val="333333"/>
                 </a:solidFill>
-                <a:latin typeface="Cascadia Code"/>
-              </a:defRPr>
-            </a:pPr>
-            <a:r>
-              <a:t>★ IExtension — 万能自定义</a:t>
+                <a:latin typeface="Segoe UI"/>
+              </a:defRPr>
+            </a:pPr>
+            <a:r>
+              <a:t>HCF 多块格式：</a:t>
             </a:r>
           </a:p>
         </p:txBody>
@@ -7212,30 +7659,66 @@
         </p:nvSpPr>
         <p:spPr>
           <a:xfrm>
-            <a:off x="7132320" y="5943600"/>
-            <a:ext cx="4572000" cy="457200"/>
-          </a:xfrm>
-          <a:prstGeom prst="rect">
-            <a:avLst/>
-          </a:prstGeom>
-          <a:noFill/>
-        </p:spPr>
-        <p:txBody>
-          <a:bodyPr wrap="square">
-            <a:spAutoFit/>
-          </a:bodyPr>
-          <a:lstStyle/>
-          <a:p>
-            <a:pPr algn="l">
-              <a:defRPr sz="1200" b="1">
-                <a:solidFill>
-                  <a:srgbClr val="4F6EF6"/>
-                </a:solidFill>
-                <a:latin typeface="Segoe UI"/>
-              </a:defRPr>
-            </a:pPr>
-            <a:r>
-              <a:t>插件 SDK: 4 行代码即可开发</a:t>
+            <a:off x="6858000" y="5486400"/>
+            <a:ext cx="4572000" cy="320040"/>
+          </a:xfrm>
+          <a:prstGeom prst="rect">
+            <a:avLst/>
+          </a:prstGeom>
+          <a:noFill/>
+        </p:spPr>
+        <p:txBody>
+          <a:bodyPr wrap="square">
+            <a:spAutoFit/>
+          </a:bodyPr>
+          <a:lstStyle/>
+          <a:p>
+            <a:pPr algn="l">
+              <a:defRPr sz="1300" b="0">
+                <a:solidFill>
+                  <a:srgbClr val="333333"/>
+                </a:solidFill>
+                <a:latin typeface="Segoe UI"/>
+              </a:defRPr>
+            </a:pPr>
+            <a:r>
+              <a:t>  [Header] [BlockCount]</a:t>
+            </a:r>
+          </a:p>
+        </p:txBody>
+      </p:sp>
+      <p:sp>
+        <p:nvSpPr>
+          <p:cNvPr id="17" name="TextBox 16"/>
+          <p:cNvSpPr txBox="1"/>
+          <p:nvPr/>
+        </p:nvSpPr>
+        <p:spPr>
+          <a:xfrm>
+            <a:off x="6858000" y="5833872"/>
+            <a:ext cx="4572000" cy="320040"/>
+          </a:xfrm>
+          <a:prstGeom prst="rect">
+            <a:avLst/>
+          </a:prstGeom>
+          <a:noFill/>
+        </p:spPr>
+        <p:txBody>
+          <a:bodyPr wrap="square">
+            <a:spAutoFit/>
+          </a:bodyPr>
+          <a:lstStyle/>
+          <a:p>
+            <a:pPr algn="l">
+              <a:defRPr sz="1300" b="0">
+                <a:solidFill>
+                  <a:srgbClr val="333333"/>
+                </a:solidFill>
+                <a:latin typeface="Segoe UI"/>
+              </a:defRPr>
+            </a:pPr>
+            <a:r>
+              <a:t>  [Len₁][Data₁][Len₂][Data₂]...</a:t>
             </a:r>
           </a:p>
         </p:txBody>
@@ -7297,7 +7780,7 @@
               </a:defRPr>
             </a:pPr>
             <a:r>
-              <a:t>BombGuard — 压缩包炸弹检测</a:t>
+              <a:t>插件架构</a:t>
             </a:r>
           </a:p>
         </p:txBody>
@@ -7353,8 +7836,8 @@
         </p:nvSpPr>
         <p:spPr>
           <a:xfrm>
-            <a:off x="6858000" y="1463040"/>
-            <a:ext cx="4572000" cy="4937760"/>
+            <a:off x="731520" y="1463040"/>
+            <a:ext cx="5943600" cy="4937760"/>
           </a:xfrm>
           <a:prstGeom prst="rect">
             <a:avLst/>
@@ -7399,7 +7882,7 @@
               </a:defRPr>
             </a:pPr>
             <a:r>
-              <a:t>📷 炸弹拦截弹窗截图</a:t>
+              <a:t>📷 接口关系图 — 建议用 demo/index.html 的接口力导向图</a:t>
             </a:r>
           </a:p>
         </p:txBody>
@@ -7412,22 +7895,22 @@
         </p:nvSpPr>
         <p:spPr>
           <a:xfrm>
-            <a:off x="731520" y="1463040"/>
-            <a:ext cx="5486400" cy="365760"/>
-          </a:xfrm>
-          <a:prstGeom prst="rect">
-            <a:avLst/>
-          </a:prstGeom>
-          <a:noFill/>
-        </p:spPr>
-        <p:txBody>
-          <a:bodyPr wrap="square">
-            <a:spAutoFit/>
-          </a:bodyPr>
-          <a:lstStyle/>
-          <a:p>
-            <a:pPr algn="l">
-              <a:defRPr sz="2000" b="1">
+            <a:off x="7132320" y="1463040"/>
+            <a:ext cx="4572000" cy="365760"/>
+          </a:xfrm>
+          <a:prstGeom prst="rect">
+            <a:avLst/>
+          </a:prstGeom>
+          <a:noFill/>
+        </p:spPr>
+        <p:txBody>
+          <a:bodyPr wrap="square">
+            <a:spAutoFit/>
+          </a:bodyPr>
+          <a:lstStyle/>
+          <a:p>
+            <a:pPr algn="l">
+              <a:defRPr sz="1800" b="1">
                 <a:solidFill>
                   <a:srgbClr val="1A1A1A"/>
                 </a:solidFill>
@@ -7435,7 +7918,7 @@
               </a:defRPr>
             </a:pPr>
             <a:r>
-              <a:t>原理</a:t>
+              <a:t>10 个可扩展接口</a:t>
             </a:r>
           </a:p>
         </p:txBody>
@@ -7448,30 +7931,30 @@
         </p:nvSpPr>
         <p:spPr>
           <a:xfrm>
-            <a:off x="731520" y="2011680"/>
-            <a:ext cx="5486400" cy="365760"/>
-          </a:xfrm>
-          <a:prstGeom prst="rect">
-            <a:avLst/>
-          </a:prstGeom>
-          <a:noFill/>
-        </p:spPr>
-        <p:txBody>
-          <a:bodyPr wrap="square">
-            <a:spAutoFit/>
-          </a:bodyPr>
-          <a:lstStyle/>
-          <a:p>
-            <a:pPr algn="l">
-              <a:defRPr sz="1500" b="0">
+            <a:off x="7132320" y="2011680"/>
+            <a:ext cx="4572000" cy="320040"/>
+          </a:xfrm>
+          <a:prstGeom prst="rect">
+            <a:avLst/>
+          </a:prstGeom>
+          <a:noFill/>
+        </p:spPr>
+        <p:txBody>
+          <a:bodyPr wrap="square">
+            <a:spAutoFit/>
+          </a:bodyPr>
+          <a:lstStyle/>
+          <a:p>
+            <a:pPr algn="l">
+              <a:defRPr sz="1200" b="0">
                 <a:solidFill>
                   <a:srgbClr val="333333"/>
                 </a:solidFill>
-                <a:latin typeface="Segoe UI"/>
-              </a:defRPr>
-            </a:pPr>
-            <a:r>
-              <a:t>1. HCF Header 中存储 original_size（原始文件大小）</a:t>
+                <a:latin typeface="Cascadia Code"/>
+              </a:defRPr>
+            </a:pPr>
+            <a:r>
+              <a:t>IEntropyCodec — 熵编码算法</a:t>
             </a:r>
           </a:p>
         </p:txBody>
@@ -7484,30 +7967,30 @@
         </p:nvSpPr>
         <p:spPr>
           <a:xfrm>
-            <a:off x="731520" y="2514600"/>
-            <a:ext cx="5486400" cy="365760"/>
-          </a:xfrm>
-          <a:prstGeom prst="rect">
-            <a:avLst/>
-          </a:prstGeom>
-          <a:noFill/>
-        </p:spPr>
-        <p:txBody>
-          <a:bodyPr wrap="square">
-            <a:spAutoFit/>
-          </a:bodyPr>
-          <a:lstStyle/>
-          <a:p>
-            <a:pPr algn="l">
-              <a:defRPr sz="1500" b="0">
+            <a:off x="7132320" y="2395728"/>
+            <a:ext cx="4572000" cy="320040"/>
+          </a:xfrm>
+          <a:prstGeom prst="rect">
+            <a:avLst/>
+          </a:prstGeom>
+          <a:noFill/>
+        </p:spPr>
+        <p:txBody>
+          <a:bodyPr wrap="square">
+            <a:spAutoFit/>
+          </a:bodyPr>
+          <a:lstStyle/>
+          <a:p>
+            <a:pPr algn="l">
+              <a:defRPr sz="1200" b="0">
                 <a:solidFill>
                   <a:srgbClr val="333333"/>
                 </a:solidFill>
-                <a:latin typeface="Segoe UI"/>
-              </a:defRPr>
-            </a:pPr>
-            <a:r>
-              <a:t>2. 解压前读取 header → 仅 276 字节，零 IO 开销</a:t>
+                <a:latin typeface="Cascadia Code"/>
+              </a:defRPr>
+            </a:pPr>
+            <a:r>
+              <a:t>ITransform — 数据变换 (BWT/MTF/RLE)</a:t>
             </a:r>
           </a:p>
         </p:txBody>
@@ -7520,30 +8003,30 @@
         </p:nvSpPr>
         <p:spPr>
           <a:xfrm>
-            <a:off x="731520" y="3017520"/>
-            <a:ext cx="5486400" cy="365760"/>
-          </a:xfrm>
-          <a:prstGeom prst="rect">
-            <a:avLst/>
-          </a:prstGeom>
-          <a:noFill/>
-        </p:spPr>
-        <p:txBody>
-          <a:bodyPr wrap="square">
-            <a:spAutoFit/>
-          </a:bodyPr>
-          <a:lstStyle/>
-          <a:p>
-            <a:pPr algn="l">
-              <a:defRPr sz="1500" b="0">
+            <a:off x="7132320" y="2779776"/>
+            <a:ext cx="4572000" cy="320040"/>
+          </a:xfrm>
+          <a:prstGeom prst="rect">
+            <a:avLst/>
+          </a:prstGeom>
+          <a:noFill/>
+        </p:spPr>
+        <p:txBody>
+          <a:bodyPr wrap="square">
+            <a:spAutoFit/>
+          </a:bodyPr>
+          <a:lstStyle/>
+          <a:p>
+            <a:pPr algn="l">
+              <a:defRPr sz="1200" b="0">
                 <a:solidFill>
                   <a:srgbClr val="333333"/>
                 </a:solidFill>
-                <a:latin typeface="Segoe UI"/>
-              </a:defRPr>
-            </a:pPr>
-            <a:r>
-              <a:t>3. 计算膨胀比 = original_size / 压缩文件大小</a:t>
+                <a:latin typeface="Cascadia Code"/>
+              </a:defRPr>
+            </a:pPr>
+            <a:r>
+              <a:t>IFilter — 预处理过滤器</a:t>
             </a:r>
           </a:p>
         </p:txBody>
@@ -7556,30 +8039,30 @@
         </p:nvSpPr>
         <p:spPr>
           <a:xfrm>
-            <a:off x="731520" y="3520440"/>
-            <a:ext cx="5486400" cy="365760"/>
-          </a:xfrm>
-          <a:prstGeom prst="rect">
-            <a:avLst/>
-          </a:prstGeom>
-          <a:noFill/>
-        </p:spPr>
-        <p:txBody>
-          <a:bodyPr wrap="square">
-            <a:spAutoFit/>
-          </a:bodyPr>
-          <a:lstStyle/>
-          <a:p>
-            <a:pPr algn="l">
-              <a:defRPr sz="1500" b="0">
+            <a:off x="7132320" y="3163824"/>
+            <a:ext cx="4572000" cy="320040"/>
+          </a:xfrm>
+          <a:prstGeom prst="rect">
+            <a:avLst/>
+          </a:prstGeom>
+          <a:noFill/>
+        </p:spPr>
+        <p:txBody>
+          <a:bodyPr wrap="square">
+            <a:spAutoFit/>
+          </a:bodyPr>
+          <a:lstStyle/>
+          <a:p>
+            <a:pPr algn="l">
+              <a:defRPr sz="1200" b="0">
                 <a:solidFill>
                   <a:srgbClr val="333333"/>
                 </a:solidFill>
-                <a:latin typeface="Segoe UI"/>
-              </a:defRPr>
-            </a:pPr>
-            <a:r>
-              <a:t>4. 若 &gt; 100:1 → 判断为炸弹 → 拒绝解压</a:t>
+                <a:latin typeface="Cascadia Code"/>
+              </a:defRPr>
+            </a:pPr>
+            <a:r>
+              <a:t>IMatchFinder — LZ77 字典匹配</a:t>
             </a:r>
           </a:p>
         </p:txBody>
@@ -7592,30 +8075,30 @@
         </p:nvSpPr>
         <p:spPr>
           <a:xfrm>
-            <a:off x="731520" y="4023360"/>
-            <a:ext cx="5486400" cy="365760"/>
-          </a:xfrm>
-          <a:prstGeom prst="rect">
-            <a:avLst/>
-          </a:prstGeom>
-          <a:noFill/>
-        </p:spPr>
-        <p:txBody>
-          <a:bodyPr wrap="square">
-            <a:spAutoFit/>
-          </a:bodyPr>
-          <a:lstStyle/>
-          <a:p>
-            <a:pPr algn="l">
-              <a:defRPr sz="1500" b="0">
+            <a:off x="7132320" y="3547872"/>
+            <a:ext cx="4572000" cy="320040"/>
+          </a:xfrm>
+          <a:prstGeom prst="rect">
+            <a:avLst/>
+          </a:prstGeom>
+          <a:noFill/>
+        </p:spPr>
+        <p:txBody>
+          <a:bodyPr wrap="square">
+            <a:spAutoFit/>
+          </a:bodyPr>
+          <a:lstStyle/>
+          <a:p>
+            <a:pPr algn="l">
+              <a:defRPr sz="1200" b="0">
                 <a:solidFill>
                   <a:srgbClr val="333333"/>
                 </a:solidFill>
-                <a:latin typeface="Segoe UI"/>
-              </a:defRPr>
-            </a:pPr>
-            <a:r>
-              <a:t>5. 递归深度检测 → 防嵌套炸弹（.hcf 套 .hcf）</a:t>
+                <a:latin typeface="Cascadia Code"/>
+              </a:defRPr>
+            </a:pPr>
+            <a:r>
+              <a:t>IChecksum — 完整性校验</a:t>
             </a:r>
           </a:p>
         </p:txBody>
@@ -7628,30 +8111,210 @@
         </p:nvSpPr>
         <p:spPr>
           <a:xfrm>
-            <a:off x="731520" y="4754880"/>
-            <a:ext cx="5486400" cy="457200"/>
-          </a:xfrm>
-          <a:prstGeom prst="rect">
-            <a:avLst/>
-          </a:prstGeom>
-          <a:noFill/>
-        </p:spPr>
-        <p:txBody>
-          <a:bodyPr wrap="square">
-            <a:spAutoFit/>
-          </a:bodyPr>
-          <a:lstStyle/>
-          <a:p>
-            <a:pPr algn="l">
-              <a:defRPr sz="1300" b="1">
-                <a:solidFill>
-                  <a:srgbClr val="D94040"/>
-                </a:solidFill>
-                <a:latin typeface="Segoe UI"/>
-              </a:defRPr>
-            </a:pPr>
-            <a:r>
-              <a:t>实际测试：291 字节文件声称 10GB → 膨胀比 3689 万:1 → 被拦截</a:t>
+            <a:off x="7132320" y="3931920"/>
+            <a:ext cx="4572000" cy="320040"/>
+          </a:xfrm>
+          <a:prstGeom prst="rect">
+            <a:avLst/>
+          </a:prstGeom>
+          <a:noFill/>
+        </p:spPr>
+        <p:txBody>
+          <a:bodyPr wrap="square">
+            <a:spAutoFit/>
+          </a:bodyPr>
+          <a:lstStyle/>
+          <a:p>
+            <a:pPr algn="l">
+              <a:defRPr sz="1200" b="0">
+                <a:solidFill>
+                  <a:srgbClr val="333333"/>
+                </a:solidFill>
+                <a:latin typeface="Cascadia Code"/>
+              </a:defRPr>
+            </a:pPr>
+            <a:r>
+              <a:t>IIOBackend — IO 后端</a:t>
+            </a:r>
+          </a:p>
+        </p:txBody>
+      </p:sp>
+      <p:sp>
+        <p:nvSpPr>
+          <p:cNvPr id="12" name="TextBox 11"/>
+          <p:cNvSpPr txBox="1"/>
+          <p:nvPr/>
+        </p:nvSpPr>
+        <p:spPr>
+          <a:xfrm>
+            <a:off x="7132320" y="4315968"/>
+            <a:ext cx="4572000" cy="320040"/>
+          </a:xfrm>
+          <a:prstGeom prst="rect">
+            <a:avLst/>
+          </a:prstGeom>
+          <a:noFill/>
+        </p:spPr>
+        <p:txBody>
+          <a:bodyPr wrap="square">
+            <a:spAutoFit/>
+          </a:bodyPr>
+          <a:lstStyle/>
+          <a:p>
+            <a:pPr algn="l">
+              <a:defRPr sz="1200" b="0">
+                <a:solidFill>
+                  <a:srgbClr val="333333"/>
+                </a:solidFill>
+                <a:latin typeface="Cascadia Code"/>
+              </a:defRPr>
+            </a:pPr>
+            <a:r>
+              <a:t>IBlockSplitter — 分块策略</a:t>
+            </a:r>
+          </a:p>
+        </p:txBody>
+      </p:sp>
+      <p:sp>
+        <p:nvSpPr>
+          <p:cNvPr id="13" name="TextBox 12"/>
+          <p:cNvSpPr txBox="1"/>
+          <p:nvPr/>
+        </p:nvSpPr>
+        <p:spPr>
+          <a:xfrm>
+            <a:off x="7132320" y="4700016"/>
+            <a:ext cx="4572000" cy="320040"/>
+          </a:xfrm>
+          <a:prstGeom prst="rect">
+            <a:avLst/>
+          </a:prstGeom>
+          <a:noFill/>
+        </p:spPr>
+        <p:txBody>
+          <a:bodyPr wrap="square">
+            <a:spAutoFit/>
+          </a:bodyPr>
+          <a:lstStyle/>
+          <a:p>
+            <a:pPr algn="l">
+              <a:defRPr sz="1200" b="0">
+                <a:solidFill>
+                  <a:srgbClr val="333333"/>
+                </a:solidFill>
+                <a:latin typeface="Cascadia Code"/>
+              </a:defRPr>
+            </a:pPr>
+            <a:r>
+              <a:t>ICompressHook / IDecompressHook</a:t>
+            </a:r>
+          </a:p>
+        </p:txBody>
+      </p:sp>
+      <p:sp>
+        <p:nvSpPr>
+          <p:cNvPr id="14" name="TextBox 13"/>
+          <p:cNvSpPr txBox="1"/>
+          <p:nvPr/>
+        </p:nvSpPr>
+        <p:spPr>
+          <a:xfrm>
+            <a:off x="7132320" y="5084064"/>
+            <a:ext cx="4572000" cy="320040"/>
+          </a:xfrm>
+          <a:prstGeom prst="rect">
+            <a:avLst/>
+          </a:prstGeom>
+          <a:noFill/>
+        </p:spPr>
+        <p:txBody>
+          <a:bodyPr wrap="square">
+            <a:spAutoFit/>
+          </a:bodyPr>
+          <a:lstStyle/>
+          <a:p>
+            <a:pPr algn="l">
+              <a:defRPr sz="1200" b="0">
+                <a:solidFill>
+                  <a:srgbClr val="333333"/>
+                </a:solidFill>
+                <a:latin typeface="Cascadia Code"/>
+              </a:defRPr>
+            </a:pPr>
+            <a:r>
+              <a:t>IObserver — 进度/日志</a:t>
+            </a:r>
+          </a:p>
+        </p:txBody>
+      </p:sp>
+      <p:sp>
+        <p:nvSpPr>
+          <p:cNvPr id="15" name="TextBox 14"/>
+          <p:cNvSpPr txBox="1"/>
+          <p:nvPr/>
+        </p:nvSpPr>
+        <p:spPr>
+          <a:xfrm>
+            <a:off x="7132320" y="5468112"/>
+            <a:ext cx="4572000" cy="320040"/>
+          </a:xfrm>
+          <a:prstGeom prst="rect">
+            <a:avLst/>
+          </a:prstGeom>
+          <a:noFill/>
+        </p:spPr>
+        <p:txBody>
+          <a:bodyPr wrap="square">
+            <a:spAutoFit/>
+          </a:bodyPr>
+          <a:lstStyle/>
+          <a:p>
+            <a:pPr algn="l">
+              <a:defRPr sz="1200" b="0">
+                <a:solidFill>
+                  <a:srgbClr val="333333"/>
+                </a:solidFill>
+                <a:latin typeface="Cascadia Code"/>
+              </a:defRPr>
+            </a:pPr>
+            <a:r>
+              <a:t>★ IExtension — 万能自定义</a:t>
+            </a:r>
+          </a:p>
+        </p:txBody>
+      </p:sp>
+      <p:sp>
+        <p:nvSpPr>
+          <p:cNvPr id="16" name="TextBox 15"/>
+          <p:cNvSpPr txBox="1"/>
+          <p:nvPr/>
+        </p:nvSpPr>
+        <p:spPr>
+          <a:xfrm>
+            <a:off x="7132320" y="5943600"/>
+            <a:ext cx="4572000" cy="457200"/>
+          </a:xfrm>
+          <a:prstGeom prst="rect">
+            <a:avLst/>
+          </a:prstGeom>
+          <a:noFill/>
+        </p:spPr>
+        <p:txBody>
+          <a:bodyPr wrap="square">
+            <a:spAutoFit/>
+          </a:bodyPr>
+          <a:lstStyle/>
+          <a:p>
+            <a:pPr algn="l">
+              <a:defRPr sz="1200" b="1">
+                <a:solidFill>
+                  <a:srgbClr val="4F6EF6"/>
+                </a:solidFill>
+                <a:latin typeface="Segoe UI"/>
+              </a:defRPr>
+            </a:pPr>
+            <a:r>
+              <a:t>插件 SDK: 4 行代码即可开发</a:t>
             </a:r>
           </a:p>
         </p:txBody>
@@ -7713,7 +8376,7 @@
               </a:defRPr>
             </a:pPr>
             <a:r>
-              <a:t>v2 桌面端 — Electron + React</a:t>
+              <a:t>BombGuard — 压缩包炸弹检测</a:t>
             </a:r>
           </a:p>
         </p:txBody>
@@ -7769,8 +8432,8 @@
         </p:nvSpPr>
         <p:spPr>
           <a:xfrm>
-            <a:off x="731520" y="1463040"/>
-            <a:ext cx="7132320" cy="4937760"/>
+            <a:off x="6858000" y="1463040"/>
+            <a:ext cx="4572000" cy="4937760"/>
           </a:xfrm>
           <a:prstGeom prst="rect">
             <a:avLst/>
@@ -7815,7 +8478,7 @@
               </a:defRPr>
             </a:pPr>
             <a:r>
-              <a:t>📷 v2 GUI 完整截图（含三主题对比）</a:t>
+              <a:t>📷 炸弹拦截弹窗截图</a:t>
             </a:r>
           </a:p>
         </p:txBody>
@@ -7828,22 +8491,58 @@
         </p:nvSpPr>
         <p:spPr>
           <a:xfrm>
-            <a:off x="8229600" y="1645920"/>
-            <a:ext cx="3474720" cy="365760"/>
-          </a:xfrm>
-          <a:prstGeom prst="rect">
-            <a:avLst/>
-          </a:prstGeom>
-          <a:noFill/>
-        </p:spPr>
-        <p:txBody>
-          <a:bodyPr wrap="square">
-            <a:spAutoFit/>
-          </a:bodyPr>
-          <a:lstStyle/>
-          <a:p>
-            <a:pPr algn="l">
-              <a:defRPr sz="1400" b="0">
+            <a:off x="731520" y="1463040"/>
+            <a:ext cx="5486400" cy="365760"/>
+          </a:xfrm>
+          <a:prstGeom prst="rect">
+            <a:avLst/>
+          </a:prstGeom>
+          <a:noFill/>
+        </p:spPr>
+        <p:txBody>
+          <a:bodyPr wrap="square">
+            <a:spAutoFit/>
+          </a:bodyPr>
+          <a:lstStyle/>
+          <a:p>
+            <a:pPr algn="l">
+              <a:defRPr sz="2000" b="1">
+                <a:solidFill>
+                  <a:srgbClr val="1A1A1A"/>
+                </a:solidFill>
+                <a:latin typeface="Segoe UI"/>
+              </a:defRPr>
+            </a:pPr>
+            <a:r>
+              <a:t>原理</a:t>
+            </a:r>
+          </a:p>
+        </p:txBody>
+      </p:sp>
+      <p:sp>
+        <p:nvSpPr>
+          <p:cNvPr id="6" name="TextBox 5"/>
+          <p:cNvSpPr txBox="1"/>
+          <p:nvPr/>
+        </p:nvSpPr>
+        <p:spPr>
+          <a:xfrm>
+            <a:off x="731520" y="2011680"/>
+            <a:ext cx="5486400" cy="365760"/>
+          </a:xfrm>
+          <a:prstGeom prst="rect">
+            <a:avLst/>
+          </a:prstGeom>
+          <a:noFill/>
+        </p:spPr>
+        <p:txBody>
+          <a:bodyPr wrap="square">
+            <a:spAutoFit/>
+          </a:bodyPr>
+          <a:lstStyle/>
+          <a:p>
+            <a:pPr algn="l">
+              <a:defRPr sz="1500" b="0">
                 <a:solidFill>
                   <a:srgbClr val="333333"/>
                 </a:solidFill>
@@ -7851,35 +8550,35 @@
               </a:defRPr>
             </a:pPr>
             <a:r>
-              <a:t>☀️/💻/🌙 三主题切换</a:t>
-            </a:r>
-          </a:p>
-        </p:txBody>
-      </p:sp>
-      <p:sp>
-        <p:nvSpPr>
-          <p:cNvPr id="6" name="TextBox 5"/>
-          <p:cNvSpPr txBox="1"/>
-          <p:nvPr/>
-        </p:nvSpPr>
-        <p:spPr>
-          <a:xfrm>
-            <a:off x="8229600" y="2148840"/>
-            <a:ext cx="3474720" cy="365760"/>
-          </a:xfrm>
-          <a:prstGeom prst="rect">
-            <a:avLst/>
-          </a:prstGeom>
-          <a:noFill/>
-        </p:spPr>
-        <p:txBody>
-          <a:bodyPr wrap="square">
-            <a:spAutoFit/>
-          </a:bodyPr>
-          <a:lstStyle/>
-          <a:p>
-            <a:pPr algn="l">
-              <a:defRPr sz="1400" b="0">
+              <a:t>1. HCF Header 中存储 original_size（原始文件大小）</a:t>
+            </a:r>
+          </a:p>
+        </p:txBody>
+      </p:sp>
+      <p:sp>
+        <p:nvSpPr>
+          <p:cNvPr id="7" name="TextBox 6"/>
+          <p:cNvSpPr txBox="1"/>
+          <p:nvPr/>
+        </p:nvSpPr>
+        <p:spPr>
+          <a:xfrm>
+            <a:off x="731520" y="2514600"/>
+            <a:ext cx="5486400" cy="365760"/>
+          </a:xfrm>
+          <a:prstGeom prst="rect">
+            <a:avLst/>
+          </a:prstGeom>
+          <a:noFill/>
+        </p:spPr>
+        <p:txBody>
+          <a:bodyPr wrap="square">
+            <a:spAutoFit/>
+          </a:bodyPr>
+          <a:lstStyle/>
+          <a:p>
+            <a:pPr algn="l">
+              <a:defRPr sz="1500" b="0">
                 <a:solidFill>
                   <a:srgbClr val="333333"/>
                 </a:solidFill>
@@ -7887,35 +8586,35 @@
               </a:defRPr>
             </a:pPr>
             <a:r>
-              <a:t>拖拽上传 + 文件列表</a:t>
-            </a:r>
-          </a:p>
-        </p:txBody>
-      </p:sp>
-      <p:sp>
-        <p:nvSpPr>
-          <p:cNvPr id="7" name="TextBox 6"/>
-          <p:cNvSpPr txBox="1"/>
-          <p:nvPr/>
-        </p:nvSpPr>
-        <p:spPr>
-          <a:xfrm>
-            <a:off x="8229600" y="2651760"/>
-            <a:ext cx="3474720" cy="365760"/>
-          </a:xfrm>
-          <a:prstGeom prst="rect">
-            <a:avLst/>
-          </a:prstGeom>
-          <a:noFill/>
-        </p:spPr>
-        <p:txBody>
-          <a:bodyPr wrap="square">
-            <a:spAutoFit/>
-          </a:bodyPr>
-          <a:lstStyle/>
-          <a:p>
-            <a:pPr algn="l">
-              <a:defRPr sz="1400" b="0">
+              <a:t>2. 解压前读取 header → 仅 276 字节，零 IO 开销</a:t>
+            </a:r>
+          </a:p>
+        </p:txBody>
+      </p:sp>
+      <p:sp>
+        <p:nvSpPr>
+          <p:cNvPr id="8" name="TextBox 7"/>
+          <p:cNvSpPr txBox="1"/>
+          <p:nvPr/>
+        </p:nvSpPr>
+        <p:spPr>
+          <a:xfrm>
+            <a:off x="731520" y="3017520"/>
+            <a:ext cx="5486400" cy="365760"/>
+          </a:xfrm>
+          <a:prstGeom prst="rect">
+            <a:avLst/>
+          </a:prstGeom>
+          <a:noFill/>
+        </p:spPr>
+        <p:txBody>
+          <a:bodyPr wrap="square">
+            <a:spAutoFit/>
+          </a:bodyPr>
+          <a:lstStyle/>
+          <a:p>
+            <a:pPr algn="l">
+              <a:defRPr sz="1500" b="0">
                 <a:solidFill>
                   <a:srgbClr val="333333"/>
                 </a:solidFill>
@@ -7923,35 +8622,35 @@
               </a:defRPr>
             </a:pPr>
             <a:r>
-              <a:t>压缩率实时估算</a:t>
-            </a:r>
-          </a:p>
-        </p:txBody>
-      </p:sp>
-      <p:sp>
-        <p:nvSpPr>
-          <p:cNvPr id="8" name="TextBox 7"/>
-          <p:cNvSpPr txBox="1"/>
-          <p:nvPr/>
-        </p:nvSpPr>
-        <p:spPr>
-          <a:xfrm>
-            <a:off x="8229600" y="3154680"/>
-            <a:ext cx="3474720" cy="365760"/>
-          </a:xfrm>
-          <a:prstGeom prst="rect">
-            <a:avLst/>
-          </a:prstGeom>
-          <a:noFill/>
-        </p:spPr>
-        <p:txBody>
-          <a:bodyPr wrap="square">
-            <a:spAutoFit/>
-          </a:bodyPr>
-          <a:lstStyle/>
-          <a:p>
-            <a:pPr algn="l">
-              <a:defRPr sz="1400" b="0">
+              <a:t>3. 计算膨胀比 = original_size / 压缩文件大小</a:t>
+            </a:r>
+          </a:p>
+        </p:txBody>
+      </p:sp>
+      <p:sp>
+        <p:nvSpPr>
+          <p:cNvPr id="9" name="TextBox 8"/>
+          <p:cNvSpPr txBox="1"/>
+          <p:nvPr/>
+        </p:nvSpPr>
+        <p:spPr>
+          <a:xfrm>
+            <a:off x="731520" y="3520440"/>
+            <a:ext cx="5486400" cy="365760"/>
+          </a:xfrm>
+          <a:prstGeom prst="rect">
+            <a:avLst/>
+          </a:prstGeom>
+          <a:noFill/>
+        </p:spPr>
+        <p:txBody>
+          <a:bodyPr wrap="square">
+            <a:spAutoFit/>
+          </a:bodyPr>
+          <a:lstStyle/>
+          <a:p>
+            <a:pPr algn="l">
+              <a:defRPr sz="1500" b="0">
                 <a:solidFill>
                   <a:srgbClr val="333333"/>
                 </a:solidFill>
@@ -7959,35 +8658,35 @@
               </a:defRPr>
             </a:pPr>
             <a:r>
-              <a:t>插件管理面板（开关 + 状态）</a:t>
-            </a:r>
-          </a:p>
-        </p:txBody>
-      </p:sp>
-      <p:sp>
-        <p:nvSpPr>
-          <p:cNvPr id="9" name="TextBox 8"/>
-          <p:cNvSpPr txBox="1"/>
-          <p:nvPr/>
-        </p:nvSpPr>
-        <p:spPr>
-          <a:xfrm>
-            <a:off x="8229600" y="3657600"/>
-            <a:ext cx="3474720" cy="365760"/>
-          </a:xfrm>
-          <a:prstGeom prst="rect">
-            <a:avLst/>
-          </a:prstGeom>
-          <a:noFill/>
-        </p:spPr>
-        <p:txBody>
-          <a:bodyPr wrap="square">
-            <a:spAutoFit/>
-          </a:bodyPr>
-          <a:lstStyle/>
-          <a:p>
-            <a:pPr algn="l">
-              <a:defRPr sz="1400" b="0">
+              <a:t>4. 若 &gt; 100:1 → 判断为炸弹 → 拒绝解压</a:t>
+            </a:r>
+          </a:p>
+        </p:txBody>
+      </p:sp>
+      <p:sp>
+        <p:nvSpPr>
+          <p:cNvPr id="10" name="TextBox 9"/>
+          <p:cNvSpPr txBox="1"/>
+          <p:nvPr/>
+        </p:nvSpPr>
+        <p:spPr>
+          <a:xfrm>
+            <a:off x="731520" y="4023360"/>
+            <a:ext cx="5486400" cy="365760"/>
+          </a:xfrm>
+          <a:prstGeom prst="rect">
+            <a:avLst/>
+          </a:prstGeom>
+          <a:noFill/>
+        </p:spPr>
+        <p:txBody>
+          <a:bodyPr wrap="square">
+            <a:spAutoFit/>
+          </a:bodyPr>
+          <a:lstStyle/>
+          <a:p>
+            <a:pPr algn="l">
+              <a:defRPr sz="1500" b="0">
                 <a:solidFill>
                   <a:srgbClr val="333333"/>
                 </a:solidFill>
@@ -7995,43 +8694,7 @@
               </a:defRPr>
             </a:pPr>
             <a:r>
-              <a:t>BombGuard 可视化拦截弹窗</a:t>
-            </a:r>
-          </a:p>
-        </p:txBody>
-      </p:sp>
-      <p:sp>
-        <p:nvSpPr>
-          <p:cNvPr id="10" name="TextBox 9"/>
-          <p:cNvSpPr txBox="1"/>
-          <p:nvPr/>
-        </p:nvSpPr>
-        <p:spPr>
-          <a:xfrm>
-            <a:off x="8229600" y="4160520"/>
-            <a:ext cx="3474720" cy="365760"/>
-          </a:xfrm>
-          <a:prstGeom prst="rect">
-            <a:avLst/>
-          </a:prstGeom>
-          <a:noFill/>
-        </p:spPr>
-        <p:txBody>
-          <a:bodyPr wrap="square">
-            <a:spAutoFit/>
-          </a:bodyPr>
-          <a:lstStyle/>
-          <a:p>
-            <a:pPr algn="l">
-              <a:defRPr sz="1400" b="0">
-                <a:solidFill>
-                  <a:srgbClr val="333333"/>
-                </a:solidFill>
-                <a:latin typeface="Segoe UI"/>
-              </a:defRPr>
-            </a:pPr>
-            <a:r>
-              <a:t>归档浏览器</a:t>
+              <a:t>5. 递归深度检测 → 防嵌套炸弹（.hcf 套 .hcf）</a:t>
             </a:r>
           </a:p>
         </p:txBody>
@@ -8044,30 +8707,30 @@
         </p:nvSpPr>
         <p:spPr>
           <a:xfrm>
-            <a:off x="8229600" y="4663440"/>
-            <a:ext cx="3474720" cy="365760"/>
-          </a:xfrm>
-          <a:prstGeom prst="rect">
-            <a:avLst/>
-          </a:prstGeom>
-          <a:noFill/>
-        </p:spPr>
-        <p:txBody>
-          <a:bodyPr wrap="square">
-            <a:spAutoFit/>
-          </a:bodyPr>
-          <a:lstStyle/>
-          <a:p>
-            <a:pPr algn="l">
-              <a:defRPr sz="1400" b="0">
-                <a:solidFill>
-                  <a:srgbClr val="333333"/>
-                </a:solidFill>
-                <a:latin typeface="Segoe UI"/>
-              </a:defRPr>
-            </a:pPr>
-            <a:r>
-              <a:t>F11 全屏模式</a:t>
+            <a:off x="731520" y="4754880"/>
+            <a:ext cx="5486400" cy="457200"/>
+          </a:xfrm>
+          <a:prstGeom prst="rect">
+            <a:avLst/>
+          </a:prstGeom>
+          <a:noFill/>
+        </p:spPr>
+        <p:txBody>
+          <a:bodyPr wrap="square">
+            <a:spAutoFit/>
+          </a:bodyPr>
+          <a:lstStyle/>
+          <a:p>
+            <a:pPr algn="l">
+              <a:defRPr sz="1300" b="1">
+                <a:solidFill>
+                  <a:srgbClr val="D94040"/>
+                </a:solidFill>
+                <a:latin typeface="Segoe UI"/>
+              </a:defRPr>
+            </a:pPr>
+            <a:r>
+              <a:t>实际测试：291 字节文件声称 10GB → 膨胀比 3689 万:1 → 被拦截</a:t>
             </a:r>
           </a:p>
         </p:txBody>

</xml_diff>